<commit_message>
Design : Poppins seule famille, tailles agrandies, références en gras, carte question adoucie
- Une seule famille « Poppins » (Regular/Italic/Bold), reconnue par PowerPoint, Keynote et Canva
- Tailles alignées sur les présentations d'origine (citations 24-36 pt, titres 38-46 pt)
- Références bibliques toujours en gras, y compris dans le plan
- Carte « interpellation » en verre dépoli blanc (16 %) au lieu du blanc plein
- Plan : lignes longues sur deux lignes plutôt que réduites

Co-Authored-By: Claude Opus 5.5 <noreply@anthropic.com>
Claude-Session: https://claude.ai/code/session_01SzJPwoimzy7qP6pheBewuR
</commit_message>
<xml_diff>
--- a/deckstyle/assets/template.pptx
+++ b/deckstyle/assets/template.pptx
@@ -634,9 +634,17 @@
             </a:avLst>
           </a:prstGeom>
           <a:solidFill>
-            <a:srgbClr val="FFFFFF"/>
-          </a:solidFill>
-          <a:ln/>
+            <a:srgbClr val="FFFFFF">
+              <a:alpha val="16000"/>
+            </a:srgbClr>
+          </a:solidFill>
+          <a:ln w="19050">
+            <a:solidFill>
+              <a:srgbClr val="FFFFFF">
+                <a:alpha val="55000"/>
+              </a:srgbClr>
+            </a:solidFill>
+          </a:ln>
         </p:spPr>
       </p:sp>
     </p:spTree>
@@ -686,8 +694,8 @@
         </p:nvSpPr>
         <p:spPr>
           <a:xfrm>
-            <a:off x="508000" y="1524000"/>
-            <a:ext cx="5461000" cy="3810000"/>
+            <a:off x="508000" y="762000"/>
+            <a:ext cx="5461000" cy="5334000"/>
           </a:xfrm>
           <a:prstGeom prst="roundRect">
             <a:avLst>
@@ -710,8 +718,8 @@
         </p:nvSpPr>
         <p:spPr>
           <a:xfrm>
-            <a:off x="6223000" y="1524000"/>
-            <a:ext cx="5461000" cy="3810000"/>
+            <a:off x="6223000" y="762000"/>
+            <a:ext cx="5461000" cy="5334000"/>
           </a:xfrm>
           <a:prstGeom prst="roundRect">
             <a:avLst>

</xml_diff>

<commit_message>
Grille 8 pt, PDF avec Poppins incorporée, carte question lisible
- Espacements sur une échelle 8/16/24/32/48, marge gauche commune (88 pt)
  et largeur de texte commune (784 pt) à toutes les slides, 48 pt de marge
  intérieure dans les cartes, centrage optique
- Le bot renvoie aussi un PDF généré avec Poppins incorporée : rendu identique
  sur téléphone et ordinateur, même sans la police installée
- Carte « interpellation » : bleu nuit opaque à 94 % avec contour blanc,
  texte blanc (le verre dépoli était illisible sur le dégradé clair)

Co-Authored-By: Claude Opus 5.5 <noreply@anthropic.com>
Claude-Session: https://claude.ai/code/session_01SzJPwoimzy7qP6pheBewuR
</commit_message>
<xml_diff>
--- a/deckstyle/assets/template.pptx
+++ b/deckstyle/assets/template.pptx
@@ -562,8 +562,8 @@
         </p:nvSpPr>
         <p:spPr>
           <a:xfrm>
-            <a:off x="508000" y="406400"/>
-            <a:ext cx="11176000" cy="6045200"/>
+            <a:off x="508000" y="508000"/>
+            <a:ext cx="11176000" cy="5842000"/>
           </a:xfrm>
           <a:prstGeom prst="roundRect">
             <a:avLst>
@@ -625,8 +625,8 @@
         </p:nvSpPr>
         <p:spPr>
           <a:xfrm>
-            <a:off x="508000" y="406400"/>
-            <a:ext cx="11176000" cy="6045200"/>
+            <a:off x="508000" y="508000"/>
+            <a:ext cx="11176000" cy="5842000"/>
           </a:xfrm>
           <a:prstGeom prst="roundRect">
             <a:avLst>
@@ -634,14 +634,14 @@
             </a:avLst>
           </a:prstGeom>
           <a:solidFill>
-            <a:srgbClr val="FFFFFF">
-              <a:alpha val="16000"/>
+            <a:srgbClr val="0E2740">
+              <a:alpha val="94000"/>
             </a:srgbClr>
           </a:solidFill>
           <a:ln w="19050">
             <a:solidFill>
               <a:srgbClr val="FFFFFF">
-                <a:alpha val="55000"/>
+                <a:alpha val="45000"/>
               </a:srgbClr>
             </a:solidFill>
           </a:ln>
@@ -694,8 +694,8 @@
         </p:nvSpPr>
         <p:spPr>
           <a:xfrm>
-            <a:off x="508000" y="762000"/>
-            <a:ext cx="5461000" cy="5334000"/>
+            <a:off x="508000" y="1016000"/>
+            <a:ext cx="5461000" cy="4826000"/>
           </a:xfrm>
           <a:prstGeom prst="roundRect">
             <a:avLst>
@@ -718,8 +718,8 @@
         </p:nvSpPr>
         <p:spPr>
           <a:xfrm>
-            <a:off x="6223000" y="762000"/>
-            <a:ext cx="5461000" cy="5334000"/>
+            <a:off x="6223000" y="1016000"/>
+            <a:ext cx="5461000" cy="4826000"/>
           </a:xfrm>
           <a:prstGeom prst="roundRect">
             <a:avLst>

</xml_diff>